<commit_message>
Update slide decks (PPTX) with talk corrections
Co-Authored-By: Claude Opus 4.8 (1M context) <noreply@anthropic.com>
</commit_message>
<xml_diff>
--- a/talks/talk1-sql-on-fhir/DD26_CT_260616_Brendan-Kowitz_SqlOnFhir.pptx
+++ b/talks/talk1-sql-on-fhir/DD26_CT_260616_Brendan-Kowitz_SqlOnFhir.pptx
@@ -10335,8 +10335,8 @@
         </p:nvSpPr>
         <p:spPr>
           <a:xfrm>
-            <a:off x="838200" y="1189104"/>
-            <a:ext cx="10515600" cy="768505"/>
+            <a:off x="838200" y="1288473"/>
+            <a:ext cx="10515600" cy="669136"/>
           </a:xfrm>
           <a:prstGeom prst="rect">
             <a:avLst/>
@@ -10344,7 +10344,7 @@
         </p:spPr>
         <p:txBody>
           <a:bodyPr anchor="ctr" anchorCtr="0">
-            <a:normAutofit lnSpcReduction="10000"/>
+            <a:normAutofit fontScale="92500" lnSpcReduction="20000"/>
           </a:bodyPr>
           <a:lstStyle/>
           <a:p>
@@ -15612,15 +15612,24 @@
                         </a:lnSpc>
                       </a:pPr>
                       <a:r>
-                        <a:rPr lang="en-US" sz="1150" b="0" strike="noStrike" spc="-1">
+                        <a:rPr lang="en-US" sz="1150" b="0" strike="noStrike" spc="-1" dirty="0">
                           <a:solidFill>
                             <a:srgbClr val="444A4D"/>
                           </a:solidFill>
                           <a:latin typeface="Consolas"/>
                         </a:rPr>
-                        <a:t>… run --views &lt;f&gt; --input &lt;f&gt; --out file.parquet</a:t>
+                        <a:t>… run --views &lt;f&gt; --input &lt;f&gt; --out </a:t>
                       </a:r>
-                      <a:endParaRPr lang="en-US" sz="1150" b="0" strike="noStrike" spc="-1">
+                      <a:r>
+                        <a:rPr lang="en-US" sz="1150" b="0" strike="noStrike" spc="-1" dirty="0" err="1">
+                          <a:solidFill>
+                            <a:srgbClr val="444A4D"/>
+                          </a:solidFill>
+                          <a:latin typeface="Consolas"/>
+                        </a:rPr>
+                        <a:t>file.parquet</a:t>
+                      </a:r>
+                      <a:endParaRPr lang="en-US" sz="1150" b="0" strike="noStrike" spc="-1" dirty="0">
                         <a:solidFill>
                           <a:srgbClr val="000000"/>
                         </a:solidFill>
@@ -15733,15 +15742,51 @@
                         </a:lnSpc>
                       </a:pPr>
                       <a:r>
-                        <a:rPr lang="en-US" sz="1150" b="0" strike="noStrike" spc="-1">
+                        <a:rPr lang="en-US" sz="1150" b="0" strike="noStrike" spc="-1" dirty="0">
                           <a:solidFill>
                             <a:srgbClr val="444A4D"/>
                           </a:solidFill>
                           <a:latin typeface="Consolas"/>
                         </a:rPr>
-                        <a:t>… run --views &lt;dir&gt; --input &lt;dir&gt; --out d/ --format csv</a:t>
+                        <a:t>… run --views &lt;</a:t>
                       </a:r>
-                      <a:endParaRPr lang="en-US" sz="1150" b="0" strike="noStrike" spc="-1">
+                      <a:r>
+                        <a:rPr lang="en-US" sz="1150" b="0" strike="noStrike" spc="-1" dirty="0" err="1">
+                          <a:solidFill>
+                            <a:srgbClr val="444A4D"/>
+                          </a:solidFill>
+                          <a:latin typeface="Consolas"/>
+                        </a:rPr>
+                        <a:t>dir</a:t>
+                      </a:r>
+                      <a:r>
+                        <a:rPr lang="en-US" sz="1150" b="0" strike="noStrike" spc="-1" dirty="0">
+                          <a:solidFill>
+                            <a:srgbClr val="444A4D"/>
+                          </a:solidFill>
+                          <a:latin typeface="Consolas"/>
+                        </a:rPr>
+                        <a:t>&gt; --input &lt;</a:t>
+                      </a:r>
+                      <a:r>
+                        <a:rPr lang="en-US" sz="1150" b="0" strike="noStrike" spc="-1" dirty="0" err="1">
+                          <a:solidFill>
+                            <a:srgbClr val="444A4D"/>
+                          </a:solidFill>
+                          <a:latin typeface="Consolas"/>
+                        </a:rPr>
+                        <a:t>dir</a:t>
+                      </a:r>
+                      <a:r>
+                        <a:rPr lang="en-US" sz="1150" b="0" strike="noStrike" spc="-1" dirty="0">
+                          <a:solidFill>
+                            <a:srgbClr val="444A4D"/>
+                          </a:solidFill>
+                          <a:latin typeface="Consolas"/>
+                        </a:rPr>
+                        <a:t>&gt; --out d/ --format csv</a:t>
+                      </a:r>
+                      <a:endParaRPr lang="en-US" sz="1150" b="0" strike="noStrike" spc="-1" dirty="0">
                         <a:solidFill>
                           <a:srgbClr val="000000"/>
                         </a:solidFill>
@@ -16032,7 +16077,7 @@
                         </a:lnSpc>
                       </a:pPr>
                       <a:r>
-                        <a:rPr lang="en-US" sz="1150" b="0" strike="noStrike" spc="-1">
+                        <a:rPr lang="en-US" sz="1150" b="0" strike="noStrike" spc="-1" dirty="0">
                           <a:solidFill>
                             <a:srgbClr val="444A4D"/>
                           </a:solidFill>
@@ -16040,7 +16085,7 @@
                         </a:rPr>
                         <a:t>Write batch statistics</a:t>
                       </a:r>
-                      <a:endParaRPr lang="en-US" sz="1150" b="0" strike="noStrike" spc="-1">
+                      <a:endParaRPr lang="en-US" sz="1150" b="0" strike="noStrike" spc="-1" dirty="0">
                         <a:solidFill>
                           <a:srgbClr val="000000"/>
                         </a:solidFill>
@@ -21289,7 +21334,7 @@
         <p:spPr>
           <a:xfrm>
             <a:off x="851570" y="1929960"/>
-            <a:ext cx="6766200" cy="901978"/>
+            <a:ext cx="6766200" cy="3099310"/>
           </a:xfrm>
           <a:prstGeom prst="rect">
             <a:avLst/>
@@ -21317,242 +21362,196 @@
           </a:bodyPr>
           <a:lstStyle/>
           <a:p>
-            <a:pPr defTabSz="914400">
-              <a:lnSpc>
-                <a:spcPct val="105000"/>
-              </a:lnSpc>
+            <a:pPr marL="228600" marR="0" lvl="0" indent="-228600" algn="l" defTabSz="914400" rtl="0" eaLnBrk="1" fontAlgn="auto" latinLnBrk="0" hangingPunct="1">
+              <a:lnSpc>
+                <a:spcPct val="90000"/>
+              </a:lnSpc>
+              <a:spcBef>
+                <a:spcPts val="1000"/>
+              </a:spcBef>
               <a:spcAft>
-                <a:spcPts val="400"/>
+                <a:spcPts val="0"/>
               </a:spcAft>
-            </a:pPr>
-            <a:r>
-              <a:rPr lang="en-US" sz="2200" b="1" strike="noStrike" spc="-1" dirty="0">
-                <a:solidFill>
-                  <a:srgbClr val="222A2E"/>
-                </a:solidFill>
-                <a:latin typeface="Calibri"/>
+              <a:buClrTx/>
+              <a:buSzTx/>
+              <a:buFont typeface="Arial"/>
+              <a:buChar char="•"/>
+              <a:tabLst/>
+              <a:defRPr/>
+            </a:pPr>
+            <a:r>
+              <a:rPr kumimoji="0" lang="en-US" sz="2800" b="1" i="0" u="none" strike="noStrike" kern="1200" cap="none" spc="0" normalizeH="0" baseline="0" noProof="0" dirty="0">
+                <a:ln>
+                  <a:noFill/>
+                </a:ln>
+                <a:solidFill>
+                  <a:prstClr val="black">
+                    <a:lumMod val="65000"/>
+                    <a:lumOff val="35000"/>
+                  </a:prstClr>
+                </a:solidFill>
+                <a:effectLst/>
+                <a:uLnTx/>
+                <a:uFillTx/>
+                <a:latin typeface="Calibri" panose="020F0502020204030204"/>
+                <a:ea typeface="+mn-ea"/>
+                <a:cs typeface="+mn-cs"/>
               </a:rPr>
               <a:t>Brendan Kowitz</a:t>
             </a:r>
-            <a:endParaRPr lang="en-US" sz="2200" b="0" strike="noStrike" spc="-1" dirty="0">
+          </a:p>
+          <a:p>
+            <a:pPr marL="228600" marR="0" lvl="0" indent="-228600" algn="l" defTabSz="914400" rtl="0" eaLnBrk="1" fontAlgn="auto" latinLnBrk="0" hangingPunct="1">
+              <a:lnSpc>
+                <a:spcPct val="90000"/>
+              </a:lnSpc>
+              <a:spcBef>
+                <a:spcPts val="1000"/>
+              </a:spcBef>
+              <a:spcAft>
+                <a:spcPts val="0"/>
+              </a:spcAft>
+              <a:buClrTx/>
+              <a:buSzTx/>
+              <a:buFont typeface="Arial"/>
+              <a:buChar char="•"/>
+              <a:tabLst/>
+              <a:defRPr/>
+            </a:pPr>
+            <a:r>
+              <a:rPr kumimoji="0" lang="en-US" sz="2800" b="0" i="0" u="none" strike="noStrike" kern="1200" cap="none" spc="0" normalizeH="0" baseline="0" noProof="0" dirty="0">
+                <a:ln>
+                  <a:noFill/>
+                </a:ln>
+                <a:solidFill>
+                  <a:prstClr val="black">
+                    <a:lumMod val="65000"/>
+                    <a:lumOff val="35000"/>
+                  </a:prstClr>
+                </a:solidFill>
+                <a:effectLst/>
+                <a:uLnTx/>
+                <a:uFillTx/>
+                <a:latin typeface="Calibri" panose="020F0502020204030204"/>
+                <a:ea typeface="+mn-ea"/>
+                <a:cs typeface="+mn-cs"/>
+              </a:rPr>
+              <a:t>Principal Software Engineering Manager, Microsoft - open-source &amp; hosted FHIR Server for Azure</a:t>
+            </a:r>
+          </a:p>
+          <a:p>
+            <a:pPr marL="228600" marR="0" lvl="0" indent="-228600" algn="l" defTabSz="914400" rtl="0" eaLnBrk="1" fontAlgn="auto" latinLnBrk="0" hangingPunct="1">
+              <a:lnSpc>
+                <a:spcPct val="90000"/>
+              </a:lnSpc>
+              <a:spcBef>
+                <a:spcPts val="1000"/>
+              </a:spcBef>
+              <a:spcAft>
+                <a:spcPts val="0"/>
+              </a:spcAft>
+              <a:buClrTx/>
+              <a:buSzTx/>
+              <a:buFont typeface="Arial"/>
+              <a:buChar char="•"/>
+              <a:tabLst/>
+              <a:defRPr/>
+            </a:pPr>
+            <a:r>
+              <a:rPr kumimoji="0" lang="en-US" sz="2800" b="0" i="0" u="none" strike="noStrike" kern="1200" cap="none" spc="0" normalizeH="0" baseline="0" noProof="0" dirty="0">
+                <a:ln>
+                  <a:noFill/>
+                </a:ln>
+                <a:solidFill>
+                  <a:prstClr val="black">
+                    <a:lumMod val="65000"/>
+                    <a:lumOff val="35000"/>
+                  </a:prstClr>
+                </a:solidFill>
+                <a:effectLst/>
+                <a:uLnTx/>
+                <a:uFillTx/>
+                <a:latin typeface="Calibri" panose="020F0502020204030204"/>
+                <a:ea typeface="+mn-ea"/>
+                <a:cs typeface="+mn-cs"/>
+              </a:rPr>
+              <a:t>Originally from Australia; now in the Pacific Northwest</a:t>
+            </a:r>
+          </a:p>
+          <a:p>
+            <a:pPr marL="228600" marR="0" lvl="0" indent="-228600" algn="l" defTabSz="914400" rtl="0" eaLnBrk="1" fontAlgn="auto" latinLnBrk="0" hangingPunct="1">
+              <a:lnSpc>
+                <a:spcPct val="90000"/>
+              </a:lnSpc>
+              <a:spcBef>
+                <a:spcPts val="1000"/>
+              </a:spcBef>
+              <a:spcAft>
+                <a:spcPts val="0"/>
+              </a:spcAft>
+              <a:buClrTx/>
+              <a:buSzTx/>
+              <a:buFont typeface="Arial"/>
+              <a:buChar char="•"/>
+              <a:tabLst/>
+              <a:defRPr/>
+            </a:pPr>
+            <a:r>
+              <a:rPr kumimoji="0" lang="en-US" sz="2800" b="0" i="0" u="none" strike="noStrike" kern="1200" cap="none" spc="0" normalizeH="0" baseline="0" noProof="0" dirty="0">
+                <a:ln>
+                  <a:noFill/>
+                </a:ln>
+                <a:solidFill>
+                  <a:prstClr val="black">
+                    <a:lumMod val="65000"/>
+                    <a:lumOff val="35000"/>
+                  </a:prstClr>
+                </a:solidFill>
+                <a:effectLst/>
+                <a:uLnTx/>
+                <a:uFillTx/>
+                <a:latin typeface="Calibri" panose="020F0502020204030204"/>
+                <a:ea typeface="+mn-ea"/>
+                <a:cs typeface="+mn-cs"/>
+              </a:rPr>
+              <a:t>github.com/</a:t>
+            </a:r>
+            <a:r>
+              <a:rPr kumimoji="0" lang="en-US" sz="2800" b="0" i="0" u="none" strike="noStrike" kern="1200" cap="none" spc="0" normalizeH="0" baseline="0" noProof="0" dirty="0" err="1">
+                <a:ln>
+                  <a:noFill/>
+                </a:ln>
+                <a:solidFill>
+                  <a:prstClr val="black">
+                    <a:lumMod val="65000"/>
+                    <a:lumOff val="35000"/>
+                  </a:prstClr>
+                </a:solidFill>
+                <a:effectLst/>
+                <a:uLnTx/>
+                <a:uFillTx/>
+                <a:latin typeface="Calibri" panose="020F0502020204030204"/>
+                <a:ea typeface="+mn-ea"/>
+                <a:cs typeface="+mn-cs"/>
+              </a:rPr>
+              <a:t>brendankowitz</a:t>
+            </a:r>
+            <a:endParaRPr kumimoji="0" lang="en-US" sz="2800" b="0" i="0" u="none" strike="noStrike" kern="1200" cap="none" spc="0" normalizeH="0" baseline="0" noProof="0" dirty="0">
+              <a:ln>
+                <a:noFill/>
+              </a:ln>
               <a:solidFill>
-                <a:srgbClr val="000000"/>
+                <a:prstClr val="black">
+                  <a:lumMod val="65000"/>
+                  <a:lumOff val="35000"/>
+                </a:prstClr>
               </a:solidFill>
-              <a:latin typeface="Arial"/>
-            </a:endParaRPr>
-          </a:p>
-          <a:p>
-            <a:pPr defTabSz="914400">
-              <a:lnSpc>
-                <a:spcPct val="105000"/>
-              </a:lnSpc>
-              <a:spcAft>
-                <a:spcPts val="400"/>
-              </a:spcAft>
-            </a:pPr>
-            <a:r>
-              <a:rPr lang="en-US" sz="1500" b="1" strike="noStrike" spc="-1" dirty="0">
-                <a:solidFill>
-                  <a:srgbClr val="0091B9"/>
-                </a:solidFill>
-                <a:latin typeface="Calibri"/>
-              </a:rPr>
-              <a:t>Principal Software Engineering Manager, Microsoft</a:t>
-            </a:r>
-            <a:endParaRPr lang="en-US" sz="1500" b="0" strike="noStrike" spc="-1" dirty="0">
-              <a:solidFill>
-                <a:srgbClr val="000000"/>
-              </a:solidFill>
-              <a:latin typeface="Arial"/>
-            </a:endParaRPr>
-          </a:p>
-          <a:p>
-            <a:pPr defTabSz="914400">
-              <a:lnSpc>
-                <a:spcPct val="105000"/>
-              </a:lnSpc>
-              <a:spcAft>
-                <a:spcPts val="400"/>
-              </a:spcAft>
-            </a:pPr>
-            <a:r>
-              <a:rPr lang="en-US" sz="1300" b="0" strike="noStrike" spc="-1" dirty="0">
-                <a:solidFill>
-                  <a:srgbClr val="444A4D"/>
-                </a:solidFill>
-                <a:latin typeface="Calibri"/>
-              </a:rPr>
-              <a:t>Azure Health Data Services</a:t>
-            </a:r>
-          </a:p>
-        </p:txBody>
-      </p:sp>
-      <p:sp>
-        <p:nvSpPr>
-          <p:cNvPr id="83" name="Rounded Rectangle 3"/>
-          <p:cNvSpPr/>
-          <p:nvPr/>
-        </p:nvSpPr>
-        <p:spPr>
-          <a:xfrm>
-            <a:off x="7955280" y="2103120"/>
-            <a:ext cx="3200040" cy="3382920"/>
-          </a:xfrm>
-          <a:prstGeom prst="roundRect">
-            <a:avLst>
-              <a:gd name="adj" fmla="val 5000"/>
-            </a:avLst>
-          </a:prstGeom>
-          <a:solidFill>
-            <a:srgbClr val="FFFFFF"/>
-          </a:solidFill>
-          <a:ln w="9525">
-            <a:solidFill>
-              <a:srgbClr val="D7DDE1"/>
-            </a:solidFill>
-          </a:ln>
-          <a:effectLst>
-            <a:outerShdw blurRad="90000" dist="38160" dir="5400000" rotWithShape="0">
-              <a:srgbClr val="1B2A33">
-                <a:alpha val="18000"/>
-              </a:srgbClr>
-            </a:outerShdw>
-          </a:effectLst>
-        </p:spPr>
-        <p:style>
-          <a:lnRef idx="1">
-            <a:schemeClr val="accent1"/>
-          </a:lnRef>
-          <a:fillRef idx="3">
-            <a:schemeClr val="accent1"/>
-          </a:fillRef>
-          <a:effectRef idx="2">
-            <a:schemeClr val="accent1"/>
-          </a:effectRef>
-          <a:fontRef idx="minor"/>
-        </p:style>
-        <p:txBody>
-          <a:bodyPr lIns="90000" tIns="45000" rIns="90000" bIns="45000" anchor="ctr">
-            <a:noAutofit/>
-          </a:bodyPr>
-          <a:lstStyle/>
-          <a:p>
-            <a:pPr algn="ctr" defTabSz="914400">
-              <a:lnSpc>
-                <a:spcPct val="100000"/>
-              </a:lnSpc>
-            </a:pPr>
-            <a:endParaRPr lang="en-US" sz="1800" b="0" strike="noStrike" spc="-1">
-              <a:solidFill>
-                <a:schemeClr val="lt1"/>
-              </a:solidFill>
-              <a:latin typeface="Calibri"/>
-            </a:endParaRPr>
-          </a:p>
-        </p:txBody>
-      </p:sp>
-      <p:sp>
-        <p:nvSpPr>
-          <p:cNvPr id="86" name="TextBox 6"/>
-          <p:cNvSpPr/>
-          <p:nvPr/>
-        </p:nvSpPr>
-        <p:spPr>
-          <a:xfrm>
-            <a:off x="7607520" y="4430000"/>
-            <a:ext cx="3996876" cy="378720"/>
-          </a:xfrm>
-          <a:prstGeom prst="rect">
-            <a:avLst/>
-          </a:prstGeom>
-          <a:noFill/>
-          <a:ln w="0">
-            <a:noFill/>
-          </a:ln>
-        </p:spPr>
-        <p:style>
-          <a:lnRef idx="0">
-            <a:scrgbClr r="0" g="0" b="0"/>
-          </a:lnRef>
-          <a:fillRef idx="0">
-            <a:scrgbClr r="0" g="0" b="0"/>
-          </a:fillRef>
-          <a:effectRef idx="0">
-            <a:scrgbClr r="0" g="0" b="0"/>
-          </a:effectRef>
-          <a:fontRef idx="minor"/>
-        </p:style>
-        <p:txBody>
-          <a:bodyPr wrap="square" lIns="0" tIns="0" rIns="0" bIns="0" anchor="t">
-            <a:spAutoFit/>
-          </a:bodyPr>
-          <a:lstStyle/>
-          <a:p>
-            <a:pPr algn="ctr" defTabSz="914400">
-              <a:lnSpc>
-                <a:spcPct val="100000"/>
-              </a:lnSpc>
-              <a:spcAft>
-                <a:spcPts val="99"/>
-              </a:spcAft>
-            </a:pPr>
-            <a:r>
-              <a:rPr lang="en-US" sz="1200" b="1" strike="noStrike" spc="-1" dirty="0">
-                <a:solidFill>
-                  <a:srgbClr val="0091B9"/>
-                </a:solidFill>
-                <a:latin typeface="Calibri"/>
-              </a:rPr>
-              <a:t>github.com/</a:t>
-            </a:r>
-            <a:r>
-              <a:rPr lang="en-US" sz="1200" b="1" strike="noStrike" spc="-1" dirty="0" err="1">
-                <a:solidFill>
-                  <a:srgbClr val="0091B9"/>
-                </a:solidFill>
-                <a:latin typeface="Calibri"/>
-              </a:rPr>
-              <a:t>brendankowitz</a:t>
-            </a:r>
-            <a:endParaRPr lang="en-US" sz="1200" b="0" strike="noStrike" spc="-1" dirty="0">
-              <a:solidFill>
-                <a:srgbClr val="000000"/>
-              </a:solidFill>
-              <a:latin typeface="Arial"/>
-            </a:endParaRPr>
-          </a:p>
-          <a:p>
-            <a:pPr algn="ctr" defTabSz="914400">
-              <a:lnSpc>
-                <a:spcPct val="100000"/>
-              </a:lnSpc>
-              <a:spcAft>
-                <a:spcPts val="99"/>
-              </a:spcAft>
-            </a:pPr>
-            <a:r>
-              <a:rPr lang="en-US" sz="1200" b="0" strike="noStrike" spc="-1" dirty="0">
-                <a:solidFill>
-                  <a:srgbClr val="444A4D"/>
-                </a:solidFill>
-                <a:latin typeface="Calibri"/>
-              </a:rPr>
-              <a:t>/</a:t>
-            </a:r>
-            <a:r>
-              <a:rPr lang="en-US" sz="1200" b="0" strike="noStrike" spc="-1" dirty="0" err="1">
-                <a:solidFill>
-                  <a:srgbClr val="444A4D"/>
-                </a:solidFill>
-                <a:latin typeface="Calibri"/>
-              </a:rPr>
-              <a:t>ignixa-fhir</a:t>
-            </a:r>
-            <a:endParaRPr lang="en-US" sz="1200" b="0" strike="noStrike" spc="-1" dirty="0">
-              <a:solidFill>
-                <a:srgbClr val="000000"/>
-              </a:solidFill>
-              <a:latin typeface="Arial"/>
+              <a:effectLst/>
+              <a:uLnTx/>
+              <a:uFillTx/>
+              <a:latin typeface="Calibri" panose="020F0502020204030204"/>
+              <a:ea typeface="+mn-ea"/>
+              <a:cs typeface="+mn-cs"/>
             </a:endParaRPr>
           </a:p>
         </p:txBody>
@@ -26122,7 +26121,7 @@
                 </a:solidFill>
                 <a:latin typeface="Calibri"/>
               </a:rPr>
-              <a:t> PERFORMANCE</a:t>
+              <a:t> performance</a:t>
             </a:r>
             <a:endParaRPr lang="en-US" sz="1200" b="0" strike="noStrike" spc="-1" dirty="0">
               <a:solidFill>
@@ -30906,4 +30905,10 @@
   <we:bindings/>
   <we:snapshot xmlns:r="http://schemas.openxmlformats.org/officeDocument/2006/relationships"/>
 </we:webextension>
+</file>
+
+<file path=docMetadata/LabelInfo.xml><?xml version="1.0" encoding="utf-8"?>
+<clbl:labelList xmlns:clbl="http://schemas.microsoft.com/office/2020/mipLabelMetadata">
+  <clbl:label id="{f42aa342-8706-4288-bd11-ebb85995028c}" enabled="1" method="Standard" siteId="{72f988bf-86f1-41af-91ab-2d7cd011db47}" contentBits="0" removed="0"/>
+</clbl:labelList>
 </file>
</xml_diff>

<commit_message>
Update SQL on FHIR slides (PPTX) and add PDF export
Co-Authored-By: Claude Opus 4.8 (1M context) <noreply@anthropic.com>
</commit_message>
<xml_diff>
--- a/talks/talk1-sql-on-fhir/DD26_CT_260616_Brendan-Kowitz_SqlOnFhir.pptx
+++ b/talks/talk1-sql-on-fhir/DD26_CT_260616_Brendan-Kowitz_SqlOnFhir.pptx
@@ -23390,6 +23390,317 @@
           </a:ln>
         </p:spPr>
       </p:pic>
+      <p:sp>
+        <p:nvSpPr>
+          <p:cNvPr id="7" name="Rounded Rectangle 3">
+            <a:extLst>
+              <a:ext uri="{FF2B5EF4-FFF2-40B4-BE49-F238E27FC236}">
+                <a16:creationId xmlns:a16="http://schemas.microsoft.com/office/drawing/2014/main" id="{C9FC17E6-7504-A307-84D7-A755B6748533}"/>
+              </a:ext>
+            </a:extLst>
+          </p:cNvPr>
+          <p:cNvSpPr/>
+          <p:nvPr/>
+        </p:nvSpPr>
+        <p:spPr>
+          <a:xfrm>
+            <a:off x="841320" y="5473700"/>
+            <a:ext cx="7680600" cy="868320"/>
+          </a:xfrm>
+          <a:prstGeom prst="roundRect">
+            <a:avLst>
+              <a:gd name="adj" fmla="val 6000"/>
+            </a:avLst>
+          </a:prstGeom>
+          <a:solidFill>
+            <a:srgbClr val="FFFFFF"/>
+          </a:solidFill>
+          <a:ln w="9525">
+            <a:solidFill>
+              <a:srgbClr val="D7DDE1"/>
+            </a:solidFill>
+          </a:ln>
+          <a:effectLst>
+            <a:outerShdw blurRad="90000" dist="38160" dir="5400000" rotWithShape="0">
+              <a:srgbClr val="1B2A33">
+                <a:alpha val="18000"/>
+              </a:srgbClr>
+            </a:outerShdw>
+          </a:effectLst>
+        </p:spPr>
+        <p:style>
+          <a:lnRef idx="1">
+            <a:schemeClr val="accent1"/>
+          </a:lnRef>
+          <a:fillRef idx="3">
+            <a:schemeClr val="accent1"/>
+          </a:fillRef>
+          <a:effectRef idx="2">
+            <a:schemeClr val="accent1"/>
+          </a:effectRef>
+          <a:fontRef idx="minor"/>
+        </p:style>
+        <p:txBody>
+          <a:bodyPr lIns="90000" tIns="45000" rIns="90000" bIns="45000" anchor="ctr">
+            <a:noAutofit/>
+          </a:bodyPr>
+          <a:lstStyle/>
+          <a:p>
+            <a:pPr algn="ctr" defTabSz="914400">
+              <a:lnSpc>
+                <a:spcPct val="100000"/>
+              </a:lnSpc>
+            </a:pPr>
+            <a:endParaRPr lang="en-US" sz="1800" b="0" strike="noStrike" spc="-1">
+              <a:solidFill>
+                <a:schemeClr val="lt1"/>
+              </a:solidFill>
+              <a:latin typeface="Calibri"/>
+            </a:endParaRPr>
+          </a:p>
+        </p:txBody>
+      </p:sp>
+      <p:sp>
+        <p:nvSpPr>
+          <p:cNvPr id="9" name="Rectangle 4">
+            <a:extLst>
+              <a:ext uri="{FF2B5EF4-FFF2-40B4-BE49-F238E27FC236}">
+                <a16:creationId xmlns:a16="http://schemas.microsoft.com/office/drawing/2014/main" id="{466B0DFD-1988-EECD-9156-F1145651469B}"/>
+              </a:ext>
+            </a:extLst>
+          </p:cNvPr>
+          <p:cNvSpPr/>
+          <p:nvPr/>
+        </p:nvSpPr>
+        <p:spPr>
+          <a:xfrm>
+            <a:off x="841320" y="5537200"/>
+            <a:ext cx="63720" cy="758520"/>
+          </a:xfrm>
+          <a:prstGeom prst="rect">
+            <a:avLst/>
+          </a:prstGeom>
+          <a:solidFill>
+            <a:srgbClr val="0091B9"/>
+          </a:solidFill>
+          <a:ln>
+            <a:noFill/>
+          </a:ln>
+        </p:spPr>
+        <p:style>
+          <a:lnRef idx="1">
+            <a:schemeClr val="accent1"/>
+          </a:lnRef>
+          <a:fillRef idx="3">
+            <a:schemeClr val="accent1"/>
+          </a:fillRef>
+          <a:effectRef idx="2">
+            <a:schemeClr val="accent1"/>
+          </a:effectRef>
+          <a:fontRef idx="minor"/>
+        </p:style>
+        <p:txBody>
+          <a:bodyPr lIns="90000" tIns="45000" rIns="90000" bIns="45000" anchor="ctr">
+            <a:noAutofit/>
+          </a:bodyPr>
+          <a:lstStyle/>
+          <a:p>
+            <a:pPr algn="ctr" defTabSz="914400">
+              <a:lnSpc>
+                <a:spcPct val="100000"/>
+              </a:lnSpc>
+            </a:pPr>
+            <a:endParaRPr lang="en-US" sz="1800" b="0" strike="noStrike" spc="-1">
+              <a:solidFill>
+                <a:schemeClr val="lt1"/>
+              </a:solidFill>
+              <a:latin typeface="Calibri"/>
+            </a:endParaRPr>
+          </a:p>
+        </p:txBody>
+      </p:sp>
+      <p:pic>
+        <p:nvPicPr>
+          <p:cNvPr id="11" name="Picture 5" descr="github.png">
+            <a:extLst>
+              <a:ext uri="{FF2B5EF4-FFF2-40B4-BE49-F238E27FC236}">
+                <a16:creationId xmlns:a16="http://schemas.microsoft.com/office/drawing/2014/main" id="{333DAFF4-90DC-10B9-D0D8-7DEFC30B4085}"/>
+              </a:ext>
+            </a:extLst>
+          </p:cNvPr>
+          <p:cNvPicPr/>
+          <p:nvPr/>
+        </p:nvPicPr>
+        <p:blipFill>
+          <a:blip r:embed="rId4"/>
+          <a:stretch/>
+        </p:blipFill>
+        <p:spPr>
+          <a:xfrm>
+            <a:off x="1115640" y="5676900"/>
+            <a:ext cx="456840" cy="456840"/>
+          </a:xfrm>
+          <a:prstGeom prst="rect">
+            <a:avLst/>
+          </a:prstGeom>
+          <a:ln w="0">
+            <a:noFill/>
+          </a:ln>
+        </p:spPr>
+      </p:pic>
+      <p:sp>
+        <p:nvSpPr>
+          <p:cNvPr id="13" name="TextBox 6">
+            <a:extLst>
+              <a:ext uri="{FF2B5EF4-FFF2-40B4-BE49-F238E27FC236}">
+                <a16:creationId xmlns:a16="http://schemas.microsoft.com/office/drawing/2014/main" id="{C81401B7-90E3-BD15-A47F-804C7A545F32}"/>
+              </a:ext>
+            </a:extLst>
+          </p:cNvPr>
+          <p:cNvSpPr/>
+          <p:nvPr/>
+        </p:nvSpPr>
+        <p:spPr>
+          <a:xfrm>
+            <a:off x="1801440" y="5626100"/>
+            <a:ext cx="6400440" cy="228960"/>
+          </a:xfrm>
+          <a:prstGeom prst="rect">
+            <a:avLst/>
+          </a:prstGeom>
+          <a:noFill/>
+          <a:ln w="0">
+            <a:noFill/>
+          </a:ln>
+        </p:spPr>
+        <p:style>
+          <a:lnRef idx="0">
+            <a:scrgbClr r="0" g="0" b="0"/>
+          </a:lnRef>
+          <a:fillRef idx="0">
+            <a:scrgbClr r="0" g="0" b="0"/>
+          </a:fillRef>
+          <a:effectRef idx="0">
+            <a:scrgbClr r="0" g="0" b="0"/>
+          </a:effectRef>
+          <a:fontRef idx="minor"/>
+        </p:style>
+        <p:txBody>
+          <a:bodyPr lIns="0" tIns="0" rIns="0" bIns="0" anchor="t">
+            <a:spAutoFit/>
+          </a:bodyPr>
+          <a:lstStyle/>
+          <a:p>
+            <a:pPr defTabSz="914400">
+              <a:lnSpc>
+                <a:spcPct val="100000"/>
+              </a:lnSpc>
+              <a:spcAft>
+                <a:spcPts val="201"/>
+              </a:spcAft>
+            </a:pPr>
+            <a:r>
+              <a:rPr lang="en-US" sz="1500" b="1" strike="noStrike" spc="-1">
+                <a:solidFill>
+                  <a:srgbClr val="222A2E"/>
+                </a:solidFill>
+                <a:latin typeface="Calibri"/>
+              </a:rPr>
+              <a:t>GitHub</a:t>
+            </a:r>
+            <a:endParaRPr lang="en-US" sz="1500" b="0" strike="noStrike" spc="-1">
+              <a:solidFill>
+                <a:srgbClr val="000000"/>
+              </a:solidFill>
+              <a:latin typeface="Arial"/>
+            </a:endParaRPr>
+          </a:p>
+        </p:txBody>
+      </p:sp>
+      <p:sp>
+        <p:nvSpPr>
+          <p:cNvPr id="15" name="TextBox 7">
+            <a:extLst>
+              <a:ext uri="{FF2B5EF4-FFF2-40B4-BE49-F238E27FC236}">
+                <a16:creationId xmlns:a16="http://schemas.microsoft.com/office/drawing/2014/main" id="{F75473D7-E098-51E0-5A3A-D29C10B82AEA}"/>
+              </a:ext>
+            </a:extLst>
+          </p:cNvPr>
+          <p:cNvSpPr/>
+          <p:nvPr/>
+        </p:nvSpPr>
+        <p:spPr>
+          <a:xfrm>
+            <a:off x="1801440" y="5956300"/>
+            <a:ext cx="6400440" cy="190800"/>
+          </a:xfrm>
+          <a:prstGeom prst="rect">
+            <a:avLst/>
+          </a:prstGeom>
+          <a:noFill/>
+          <a:ln w="0">
+            <a:noFill/>
+          </a:ln>
+        </p:spPr>
+        <p:style>
+          <a:lnRef idx="0">
+            <a:scrgbClr r="0" g="0" b="0"/>
+          </a:lnRef>
+          <a:fillRef idx="0">
+            <a:scrgbClr r="0" g="0" b="0"/>
+          </a:fillRef>
+          <a:effectRef idx="0">
+            <a:scrgbClr r="0" g="0" b="0"/>
+          </a:effectRef>
+          <a:fontRef idx="minor"/>
+        </p:style>
+        <p:txBody>
+          <a:bodyPr lIns="0" tIns="0" rIns="0" bIns="0" anchor="t">
+            <a:spAutoFit/>
+          </a:bodyPr>
+          <a:lstStyle/>
+          <a:p>
+            <a:pPr>
+              <a:spcAft>
+                <a:spcPts val="201"/>
+              </a:spcAft>
+            </a:pPr>
+            <a:r>
+              <a:rPr lang="en-US" sz="1250" spc="-1" dirty="0">
+                <a:solidFill>
+                  <a:srgbClr val="006E8C"/>
+                </a:solidFill>
+                <a:latin typeface="Consolas"/>
+              </a:rPr>
+              <a:t>github.com/</a:t>
+            </a:r>
+            <a:r>
+              <a:rPr lang="en-US" sz="1250" spc="-1" dirty="0" err="1">
+                <a:solidFill>
+                  <a:srgbClr val="006E8C"/>
+                </a:solidFill>
+                <a:latin typeface="Consolas"/>
+              </a:rPr>
+              <a:t>brendankowitz</a:t>
+            </a:r>
+            <a:r>
+              <a:rPr lang="en-US" sz="1250" spc="-1" dirty="0">
+                <a:solidFill>
+                  <a:srgbClr val="006E8C"/>
+                </a:solidFill>
+                <a:latin typeface="Consolas"/>
+              </a:rPr>
+              <a:t>/FHIRDevDays2026</a:t>
+            </a:r>
+            <a:endParaRPr lang="en-US" sz="1250" b="0" strike="noStrike" spc="-1" dirty="0">
+              <a:solidFill>
+                <a:srgbClr val="000000"/>
+              </a:solidFill>
+              <a:latin typeface="Arial"/>
+            </a:endParaRPr>
+          </a:p>
+        </p:txBody>
+      </p:sp>
     </p:spTree>
   </p:cSld>
   <p:clrMapOvr>
@@ -23471,18 +23782,178 @@
       </p:sp>
       <p:sp>
         <p:nvSpPr>
-          <p:cNvPr id="378" name="PlaceHolder 2"/>
-          <p:cNvSpPr>
-            <a:spLocks noGrp="1"/>
-          </p:cNvSpPr>
-          <p:nvPr>
-            <p:ph/>
-          </p:nvPr>
-        </p:nvSpPr>
-        <p:spPr>
-          <a:xfrm>
-            <a:off x="838080" y="1997280"/>
-            <a:ext cx="11019960" cy="4224960"/>
+          <p:cNvPr id="7" name="Rounded Rectangle 3">
+            <a:extLst>
+              <a:ext uri="{FF2B5EF4-FFF2-40B4-BE49-F238E27FC236}">
+                <a16:creationId xmlns:a16="http://schemas.microsoft.com/office/drawing/2014/main" id="{051E6109-1525-E749-BD49-E512FB560288}"/>
+              </a:ext>
+            </a:extLst>
+          </p:cNvPr>
+          <p:cNvSpPr/>
+          <p:nvPr/>
+        </p:nvSpPr>
+        <p:spPr>
+          <a:xfrm>
+            <a:off x="2179669" y="3262514"/>
+            <a:ext cx="7680600" cy="868320"/>
+          </a:xfrm>
+          <a:prstGeom prst="roundRect">
+            <a:avLst>
+              <a:gd name="adj" fmla="val 6000"/>
+            </a:avLst>
+          </a:prstGeom>
+          <a:solidFill>
+            <a:srgbClr val="FFFFFF"/>
+          </a:solidFill>
+          <a:ln w="9525">
+            <a:solidFill>
+              <a:srgbClr val="D7DDE1"/>
+            </a:solidFill>
+          </a:ln>
+          <a:effectLst>
+            <a:outerShdw blurRad="90000" dist="38160" dir="5400000" rotWithShape="0">
+              <a:srgbClr val="1B2A33">
+                <a:alpha val="18000"/>
+              </a:srgbClr>
+            </a:outerShdw>
+          </a:effectLst>
+        </p:spPr>
+        <p:style>
+          <a:lnRef idx="1">
+            <a:schemeClr val="accent1"/>
+          </a:lnRef>
+          <a:fillRef idx="3">
+            <a:schemeClr val="accent1"/>
+          </a:fillRef>
+          <a:effectRef idx="2">
+            <a:schemeClr val="accent1"/>
+          </a:effectRef>
+          <a:fontRef idx="minor"/>
+        </p:style>
+        <p:txBody>
+          <a:bodyPr lIns="90000" tIns="45000" rIns="90000" bIns="45000" anchor="ctr">
+            <a:noAutofit/>
+          </a:bodyPr>
+          <a:lstStyle/>
+          <a:p>
+            <a:pPr algn="ctr" defTabSz="914400">
+              <a:lnSpc>
+                <a:spcPct val="100000"/>
+              </a:lnSpc>
+            </a:pPr>
+            <a:endParaRPr lang="en-US" sz="1800" b="0" strike="noStrike" spc="-1">
+              <a:solidFill>
+                <a:schemeClr val="lt1"/>
+              </a:solidFill>
+              <a:latin typeface="Calibri"/>
+            </a:endParaRPr>
+          </a:p>
+        </p:txBody>
+      </p:sp>
+      <p:sp>
+        <p:nvSpPr>
+          <p:cNvPr id="9" name="Rectangle 4">
+            <a:extLst>
+              <a:ext uri="{FF2B5EF4-FFF2-40B4-BE49-F238E27FC236}">
+                <a16:creationId xmlns:a16="http://schemas.microsoft.com/office/drawing/2014/main" id="{3A10D10F-E3E6-EA92-F5CD-A8AA6F3E0D48}"/>
+              </a:ext>
+            </a:extLst>
+          </p:cNvPr>
+          <p:cNvSpPr/>
+          <p:nvPr/>
+        </p:nvSpPr>
+        <p:spPr>
+          <a:xfrm>
+            <a:off x="2179669" y="3326014"/>
+            <a:ext cx="63720" cy="758520"/>
+          </a:xfrm>
+          <a:prstGeom prst="rect">
+            <a:avLst/>
+          </a:prstGeom>
+          <a:solidFill>
+            <a:srgbClr val="0091B9"/>
+          </a:solidFill>
+          <a:ln>
+            <a:noFill/>
+          </a:ln>
+        </p:spPr>
+        <p:style>
+          <a:lnRef idx="1">
+            <a:schemeClr val="accent1"/>
+          </a:lnRef>
+          <a:fillRef idx="3">
+            <a:schemeClr val="accent1"/>
+          </a:fillRef>
+          <a:effectRef idx="2">
+            <a:schemeClr val="accent1"/>
+          </a:effectRef>
+          <a:fontRef idx="minor"/>
+        </p:style>
+        <p:txBody>
+          <a:bodyPr lIns="90000" tIns="45000" rIns="90000" bIns="45000" anchor="ctr">
+            <a:noAutofit/>
+          </a:bodyPr>
+          <a:lstStyle/>
+          <a:p>
+            <a:pPr algn="ctr" defTabSz="914400">
+              <a:lnSpc>
+                <a:spcPct val="100000"/>
+              </a:lnSpc>
+            </a:pPr>
+            <a:endParaRPr lang="en-US" sz="1800" b="0" strike="noStrike" spc="-1">
+              <a:solidFill>
+                <a:schemeClr val="lt1"/>
+              </a:solidFill>
+              <a:latin typeface="Calibri"/>
+            </a:endParaRPr>
+          </a:p>
+        </p:txBody>
+      </p:sp>
+      <p:pic>
+        <p:nvPicPr>
+          <p:cNvPr id="11" name="Picture 5" descr="github.png">
+            <a:extLst>
+              <a:ext uri="{FF2B5EF4-FFF2-40B4-BE49-F238E27FC236}">
+                <a16:creationId xmlns:a16="http://schemas.microsoft.com/office/drawing/2014/main" id="{4BF9081B-577E-0D93-42CC-D3A21C1E0D24}"/>
+              </a:ext>
+            </a:extLst>
+          </p:cNvPr>
+          <p:cNvPicPr/>
+          <p:nvPr/>
+        </p:nvPicPr>
+        <p:blipFill>
+          <a:blip r:embed="rId3"/>
+          <a:stretch/>
+        </p:blipFill>
+        <p:spPr>
+          <a:xfrm>
+            <a:off x="2453989" y="3465714"/>
+            <a:ext cx="456840" cy="456840"/>
+          </a:xfrm>
+          <a:prstGeom prst="rect">
+            <a:avLst/>
+          </a:prstGeom>
+          <a:ln w="0">
+            <a:noFill/>
+          </a:ln>
+        </p:spPr>
+      </p:pic>
+      <p:sp>
+        <p:nvSpPr>
+          <p:cNvPr id="13" name="TextBox 6">
+            <a:extLst>
+              <a:ext uri="{FF2B5EF4-FFF2-40B4-BE49-F238E27FC236}">
+                <a16:creationId xmlns:a16="http://schemas.microsoft.com/office/drawing/2014/main" id="{1CB01E61-F166-C482-54CA-D58194703196}"/>
+              </a:ext>
+            </a:extLst>
+          </p:cNvPr>
+          <p:cNvSpPr/>
+          <p:nvPr/>
+        </p:nvSpPr>
+        <p:spPr>
+          <a:xfrm>
+            <a:off x="3139789" y="3414914"/>
+            <a:ext cx="6400440" cy="228960"/>
           </a:xfrm>
           <a:prstGeom prst="rect">
             <a:avLst/>
@@ -23492,29 +23963,130 @@
             <a:noFill/>
           </a:ln>
         </p:spPr>
-        <p:txBody>
-          <a:bodyPr lIns="90000" tIns="45000" rIns="90000" bIns="45000" anchor="t">
-            <a:noAutofit/>
+        <p:style>
+          <a:lnRef idx="0">
+            <a:scrgbClr r="0" g="0" b="0"/>
+          </a:lnRef>
+          <a:fillRef idx="0">
+            <a:scrgbClr r="0" g="0" b="0"/>
+          </a:fillRef>
+          <a:effectRef idx="0">
+            <a:scrgbClr r="0" g="0" b="0"/>
+          </a:effectRef>
+          <a:fontRef idx="minor"/>
+        </p:style>
+        <p:txBody>
+          <a:bodyPr lIns="0" tIns="0" rIns="0" bIns="0" anchor="t">
+            <a:spAutoFit/>
           </a:bodyPr>
           <a:lstStyle/>
           <a:p>
-            <a:pPr indent="0">
-              <a:lnSpc>
-                <a:spcPct val="90000"/>
-              </a:lnSpc>
-              <a:spcBef>
-                <a:spcPts val="1417"/>
-              </a:spcBef>
-              <a:buNone/>
+            <a:pPr defTabSz="914400">
+              <a:lnSpc>
+                <a:spcPct val="100000"/>
+              </a:lnSpc>
+              <a:spcAft>
+                <a:spcPts val="201"/>
+              </a:spcAft>
             </a:pPr>
-            <a:endParaRPr lang="en-US" sz="2800" b="0" strike="noStrike" spc="-1">
+            <a:r>
+              <a:rPr lang="en-US" sz="1500" b="1" strike="noStrike" spc="-1">
+                <a:solidFill>
+                  <a:srgbClr val="222A2E"/>
+                </a:solidFill>
+                <a:latin typeface="Calibri"/>
+              </a:rPr>
+              <a:t>GitHub</a:t>
+            </a:r>
+            <a:endParaRPr lang="en-US" sz="1500" b="0" strike="noStrike" spc="-1">
               <a:solidFill>
-                <a:schemeClr val="dk1">
-                  <a:lumMod val="65000"/>
-                  <a:lumOff val="35000"/>
-                </a:schemeClr>
+                <a:srgbClr val="000000"/>
               </a:solidFill>
-              <a:latin typeface="Calibri"/>
+              <a:latin typeface="Arial"/>
+            </a:endParaRPr>
+          </a:p>
+        </p:txBody>
+      </p:sp>
+      <p:sp>
+        <p:nvSpPr>
+          <p:cNvPr id="15" name="TextBox 7">
+            <a:extLst>
+              <a:ext uri="{FF2B5EF4-FFF2-40B4-BE49-F238E27FC236}">
+                <a16:creationId xmlns:a16="http://schemas.microsoft.com/office/drawing/2014/main" id="{AE4F3507-0F47-1A49-D3DE-335A4E7E78FF}"/>
+              </a:ext>
+            </a:extLst>
+          </p:cNvPr>
+          <p:cNvSpPr/>
+          <p:nvPr/>
+        </p:nvSpPr>
+        <p:spPr>
+          <a:xfrm>
+            <a:off x="3139789" y="3745114"/>
+            <a:ext cx="6400440" cy="190800"/>
+          </a:xfrm>
+          <a:prstGeom prst="rect">
+            <a:avLst/>
+          </a:prstGeom>
+          <a:noFill/>
+          <a:ln w="0">
+            <a:noFill/>
+          </a:ln>
+        </p:spPr>
+        <p:style>
+          <a:lnRef idx="0">
+            <a:scrgbClr r="0" g="0" b="0"/>
+          </a:lnRef>
+          <a:fillRef idx="0">
+            <a:scrgbClr r="0" g="0" b="0"/>
+          </a:fillRef>
+          <a:effectRef idx="0">
+            <a:scrgbClr r="0" g="0" b="0"/>
+          </a:effectRef>
+          <a:fontRef idx="minor"/>
+        </p:style>
+        <p:txBody>
+          <a:bodyPr lIns="0" tIns="0" rIns="0" bIns="0" anchor="t">
+            <a:spAutoFit/>
+          </a:bodyPr>
+          <a:lstStyle/>
+          <a:p>
+            <a:pPr>
+              <a:spcAft>
+                <a:spcPts val="201"/>
+              </a:spcAft>
+            </a:pPr>
+            <a:r>
+              <a:rPr lang="en-US" sz="1250" spc="-1" dirty="0">
+                <a:solidFill>
+                  <a:srgbClr val="006E8C"/>
+                </a:solidFill>
+                <a:latin typeface="Consolas"/>
+              </a:rPr>
+              <a:t>github.com/</a:t>
+            </a:r>
+            <a:r>
+              <a:rPr lang="en-US" sz="1250" spc="-1" dirty="0" err="1">
+                <a:solidFill>
+                  <a:srgbClr val="006E8C"/>
+                </a:solidFill>
+                <a:latin typeface="Consolas"/>
+              </a:rPr>
+              <a:t>brendankowitz</a:t>
+            </a:r>
+            <a:r>
+              <a:rPr lang="en-US" sz="1250" spc="-1" dirty="0">
+                <a:solidFill>
+                  <a:srgbClr val="006E8C"/>
+                </a:solidFill>
+                <a:latin typeface="Consolas"/>
+              </a:rPr>
+              <a:t>/FHIRDevDays2026</a:t>
+            </a:r>
+            <a:endParaRPr lang="en-US" sz="1250" b="0" strike="noStrike" spc="-1" dirty="0">
+              <a:solidFill>
+                <a:srgbClr val="000000"/>
+              </a:solidFill>
+              <a:latin typeface="Arial"/>
             </a:endParaRPr>
           </a:p>
         </p:txBody>

</xml_diff>